<commit_message>
feat: add PowerPoint and PDF generation services
- Implemented `setWorksheetCell` function for managing Excel-like worksheets in PPTX files.
- Created `setText` and `fillTable` functions for handling text and table data in PPTX presentations.
- Developed PDF generation routes with validation for document IDs and query parameters.
- Added presentation generation routes, including demo report and template exports.
- Introduced `GeneratedPresentationService` for rendering presentations using templates.
- Implemented `PowerPointTemplateService` for processing PPTX templates with dynamic content.
- Created `TemplateReportDemoService` for generating demo reports with random data.
- Added `WebPagePdfService` for rendering web pages to PDF using Playwright.
- Implemented tests for PowerPoint template processing and demo report generation.
- Added tests for web page PDF generation, including error handling and query parameter validation.
</commit_message>
<xml_diff>
--- a/templates/daa.pptx
+++ b/templates/daa.pptx
@@ -215,16 +215,16 @@
                 <c:formatCode>General</c:formatCode>
                 <c:ptCount val="4"/>
                 <c:pt idx="0">
-                  <c:v>4.3</c:v>
+                  <c:v>13</c:v>
                 </c:pt>
                 <c:pt idx="1">
-                  <c:v>2.5</c:v>
+                  <c:v>68</c:v>
                 </c:pt>
                 <c:pt idx="2">
-                  <c:v>3.5</c:v>
+                  <c:v>16</c:v>
                 </c:pt>
                 <c:pt idx="3">
-                  <c:v>4.5</c:v>
+                  <c:v>28</c:v>
                 </c:pt>
               </c:numCache>
             </c:numRef>
@@ -289,16 +289,16 @@
                 <c:formatCode>General</c:formatCode>
                 <c:ptCount val="4"/>
                 <c:pt idx="0">
-                  <c:v>2.4</c:v>
+                  <c:v>92</c:v>
                 </c:pt>
                 <c:pt idx="1">
-                  <c:v>4.4000000000000004</c:v>
+                  <c:v>84</c:v>
                 </c:pt>
                 <c:pt idx="2">
-                  <c:v>1.8</c:v>
+                  <c:v>85</c:v>
                 </c:pt>
                 <c:pt idx="3">
-                  <c:v>2.8</c:v>
+                  <c:v>69</c:v>
                 </c:pt>
               </c:numCache>
             </c:numRef>
@@ -363,16 +363,16 @@
                 <c:formatCode>General</c:formatCode>
                 <c:ptCount val="4"/>
                 <c:pt idx="0">
-                  <c:v>2</c:v>
+                  <c:v>61</c:v>
                 </c:pt>
                 <c:pt idx="1">
-                  <c:v>2</c:v>
+                  <c:v>10</c:v>
                 </c:pt>
                 <c:pt idx="2">
-                  <c:v>3</c:v>
+                  <c:v>73</c:v>
                 </c:pt>
                 <c:pt idx="3">
-                  <c:v>5</c:v>
+                  <c:v>96</c:v>
                 </c:pt>
               </c:numCache>
             </c:numRef>
@@ -1683,7 +1683,7 @@
       </p:grpSpPr>
       <p:graphicFrame>
         <p:nvGraphicFramePr>
-          <p:cNvPr id="5" name="Table 4">
+          <p:cNvPr id="5" name="TAB100">
             <a:extLst>
               <a:ext uri="{FF2B5EF4-FFF2-40B4-BE49-F238E27FC236}">
                 <a16:creationId xmlns:a16="http://schemas.microsoft.com/office/drawing/2014/main" id="{07872A09-B2FE-F289-101E-F1EFF9F5CD00}"/>
@@ -1696,7 +1696,7 @@
           <p:nvPr>
             <p:extLst>
               <p:ext uri="{D42A27DB-BD31-4B8C-83A1-F6EECF244321}">
-                <p14:modId xmlns:p14="http://schemas.microsoft.com/office/powerpoint/2010/main" val="2140280078"/>
+                <p14:modId xmlns:p14="http://schemas.microsoft.com/office/powerpoint/2010/main" val="1442127454"/>
               </p:ext>
             </p:extLst>
           </p:nvPr>
@@ -1749,7 +1749,7 @@
                     <a:p>
                       <a:r>
                         <a:rPr lang="pl-PL" dirty="0"/>
-                        <a:t>a</a:t>
+                        <a:t>11</a:t>
                       </a:r>
                     </a:p>
                   </a:txBody>
@@ -1760,7 +1760,10 @@
                     <a:bodyPr/>
                     <a:lstStyle/>
                     <a:p>
-                      <a:endParaRPr lang="pl-PL" dirty="0"/>
+                      <a:r>
+                        <a:rPr lang="pl-PL" dirty="0"/>
+                        <a:t>13</a:t>
+                      </a:r>
                     </a:p>
                   </a:txBody>
                   <a:tcPr/>
@@ -1770,7 +1773,10 @@
                     <a:bodyPr/>
                     <a:lstStyle/>
                     <a:p>
-                      <a:endParaRPr lang="pl-PL"/>
+                      <a:r>
+                        <a:rPr lang="pl-PL"/>
+                        <a:t>92</a:t>
+                      </a:r>
                     </a:p>
                   </a:txBody>
                   <a:tcPr/>
@@ -1780,7 +1786,10 @@
                     <a:bodyPr/>
                     <a:lstStyle/>
                     <a:p>
-                      <a:endParaRPr lang="pl-PL"/>
+                      <a:r>
+                        <a:rPr lang="pl-PL"/>
+                        <a:t>61</a:t>
+                      </a:r>
                     </a:p>
                   </a:txBody>
                   <a:tcPr/>
@@ -1797,7 +1806,10 @@
                     <a:bodyPr/>
                     <a:lstStyle/>
                     <a:p>
-                      <a:endParaRPr lang="pl-PL" dirty="0"/>
+                      <a:r>
+                        <a:rPr lang="pl-PL" dirty="0"/>
+                        <a:t>20</a:t>
+                      </a:r>
                     </a:p>
                   </a:txBody>
                   <a:tcPr/>
@@ -1809,7 +1821,7 @@
                     <a:p>
                       <a:r>
                         <a:rPr lang="pl-PL" dirty="0"/>
-                        <a:t>3</a:t>
+                        <a:t>68</a:t>
                       </a:r>
                     </a:p>
                   </a:txBody>
@@ -1820,7 +1832,10 @@
                     <a:bodyPr/>
                     <a:lstStyle/>
                     <a:p>
-                      <a:endParaRPr lang="pl-PL" dirty="0"/>
+                      <a:r>
+                        <a:rPr lang="pl-PL" dirty="0"/>
+                        <a:t>84</a:t>
+                      </a:r>
                     </a:p>
                   </a:txBody>
                   <a:tcPr/>
@@ -1830,7 +1845,10 @@
                     <a:bodyPr/>
                     <a:lstStyle/>
                     <a:p>
-                      <a:endParaRPr lang="pl-PL"/>
+                      <a:r>
+                        <a:rPr lang="pl-PL"/>
+                        <a:t>10</a:t>
+                      </a:r>
                     </a:p>
                   </a:txBody>
                   <a:tcPr/>
@@ -1847,17 +1865,10 @@
                     <a:bodyPr/>
                     <a:lstStyle/>
                     <a:p>
-                      <a:endParaRPr lang="pl-PL"/>
-                    </a:p>
-                  </a:txBody>
-                  <a:tcPr/>
-                </a:tc>
-                <a:tc>
-                  <a:txBody>
-                    <a:bodyPr/>
-                    <a:lstStyle/>
-                    <a:p>
-                      <a:endParaRPr lang="pl-PL"/>
+                      <a:r>
+                        <a:rPr lang="pl-PL"/>
+                        <a:t>100</a:t>
+                      </a:r>
                     </a:p>
                   </a:txBody>
                   <a:tcPr/>
@@ -1868,8 +1879,8 @@
                     <a:lstStyle/>
                     <a:p>
                       <a:r>
-                        <a:rPr lang="pl-PL" dirty="0"/>
-                        <a:t>2</a:t>
+                        <a:rPr lang="pl-PL"/>
+                        <a:t>16</a:t>
                       </a:r>
                     </a:p>
                   </a:txBody>
@@ -1882,7 +1893,20 @@
                     <a:p>
                       <a:r>
                         <a:rPr lang="pl-PL" dirty="0"/>
-                        <a:t>4</a:t>
+                        <a:t>85</a:t>
+                      </a:r>
+                    </a:p>
+                  </a:txBody>
+                  <a:tcPr/>
+                </a:tc>
+                <a:tc>
+                  <a:txBody>
+                    <a:bodyPr/>
+                    <a:lstStyle/>
+                    <a:p>
+                      <a:r>
+                        <a:rPr lang="pl-PL" dirty="0"/>
+                        <a:t>73</a:t>
                       </a:r>
                     </a:p>
                   </a:txBody>
@@ -1900,17 +1924,10 @@
                     <a:bodyPr/>
                     <a:lstStyle/>
                     <a:p>
-                      <a:endParaRPr lang="pl-PL"/>
-                    </a:p>
-                  </a:txBody>
-                  <a:tcPr/>
-                </a:tc>
-                <a:tc>
-                  <a:txBody>
-                    <a:bodyPr/>
-                    <a:lstStyle/>
-                    <a:p>
-                      <a:endParaRPr lang="pl-PL" dirty="0"/>
+                      <a:r>
+                        <a:rPr lang="pl-PL"/>
+                        <a:t>87</a:t>
+                      </a:r>
                     </a:p>
                   </a:txBody>
                   <a:tcPr/>
@@ -1922,7 +1939,7 @@
                     <a:p>
                       <a:r>
                         <a:rPr lang="pl-PL" dirty="0"/>
-                        <a:t>1</a:t>
+                        <a:t>28</a:t>
                       </a:r>
                     </a:p>
                   </a:txBody>
@@ -1933,7 +1950,23 @@
                     <a:bodyPr/>
                     <a:lstStyle/>
                     <a:p>
-                      <a:endParaRPr lang="pl-PL" dirty="0"/>
+                      <a:r>
+                        <a:rPr lang="pl-PL" dirty="0"/>
+                        <a:t>69</a:t>
+                      </a:r>
+                    </a:p>
+                  </a:txBody>
+                  <a:tcPr/>
+                </a:tc>
+                <a:tc>
+                  <a:txBody>
+                    <a:bodyPr/>
+                    <a:lstStyle/>
+                    <a:p>
+                      <a:r>
+                        <a:rPr lang="pl-PL" dirty="0"/>
+                        <a:t>96</a:t>
+                      </a:r>
                     </a:p>
                   </a:txBody>
                   <a:tcPr/>
@@ -1950,7 +1983,7 @@
       </p:graphicFrame>
       <p:graphicFrame>
         <p:nvGraphicFramePr>
-          <p:cNvPr id="8" name="Chart 7">
+          <p:cNvPr id="8" name="GGO">
             <a:extLst>
               <a:ext uri="{FF2B5EF4-FFF2-40B4-BE49-F238E27FC236}">
                 <a16:creationId xmlns:a16="http://schemas.microsoft.com/office/drawing/2014/main" id="{D13529E7-ED2F-0F17-600F-8DEFFFA51339}"/>
@@ -1961,7 +1994,7 @@
           <p:nvPr>
             <p:extLst>
               <p:ext uri="{D42A27DB-BD31-4B8C-83A1-F6EECF244321}">
-                <p14:modId xmlns:p14="http://schemas.microsoft.com/office/powerpoint/2010/main" val="670368408"/>
+                <p14:modId xmlns:p14="http://schemas.microsoft.com/office/powerpoint/2010/main" val="1859381432"/>
               </p:ext>
             </p:extLst>
           </p:nvPr>
@@ -1976,6 +2009,48 @@
           </a:graphicData>
         </a:graphic>
       </p:graphicFrame>
+      <p:sp>
+        <p:nvSpPr>
+          <p:cNvPr id="2" name="TEXT_ME">
+            <a:extLst>
+              <a:ext uri="{FF2B5EF4-FFF2-40B4-BE49-F238E27FC236}">
+                <a16:creationId xmlns:a16="http://schemas.microsoft.com/office/drawing/2014/main" id="{72AE51A0-7917-BB35-54C8-701679102832}"/>
+              </a:ext>
+            </a:extLst>
+          </p:cNvPr>
+          <p:cNvSpPr txBox="1"/>
+          <p:nvPr/>
+        </p:nvSpPr>
+        <p:spPr>
+          <a:xfrm>
+            <a:off x="6182436" y="825690"/>
+            <a:ext cx="3432412" cy="369332"/>
+          </a:xfrm>
+          <a:prstGeom prst="rect">
+            <a:avLst/>
+          </a:prstGeom>
+          <a:noFill/>
+        </p:spPr>
+        <p:txBody>
+          <a:bodyPr wrap="square" rtlCol="0">
+            <a:spAutoFit/>
+          </a:bodyPr>
+          <a:lstStyle/>
+          <a:p>
+            <a:r>
+              <a:rPr lang="pl-PL" dirty="0">
+                <a:solidFill>
+                  <a:schemeClr val="accent4">
+                    <a:lumMod val="40000"/>
+                    <a:lumOff val="60000"/>
+                  </a:schemeClr>
+                </a:solidFill>
+              </a:rPr>
+              <a:t>EXAMPLE</a:t>
+            </a:r>
+          </a:p>
+        </p:txBody>
+      </p:sp>
     </p:spTree>
   </p:cSld>
   <p:clrMapOvr>

</xml_diff>